<commit_message>
docs(entregas): pitch atualizado, Entrega 4, Plano de Trabalho FAPEG e log de sessao
Atualiza o pitch (pptx/pdf) e o roteiro de 3 min, adiciona a Entrega 4 e o
Plano de Trabalho FAPEG (docx/pdf, controle interno xlsx, fonte conteudo.py e
DECISIONS.md) e registra as sessoes de 23/09 a 07/10 no SESSION_LOG.

Co-Authored-By: Claude Sonnet 5.5 <noreply@anthropic.com>
</commit_message>
<xml_diff>
--- a/prototipo/VIA_LEITE_SENSE_Pitch.pptx
+++ b/prototipo/VIA_LEITE_SENSE_Pitch.pptx
@@ -4998,7 +4998,7 @@
                 <a:ea typeface="Calibri" pitchFamily="34" charset="-122"/>
                 <a:cs typeface="Calibri" pitchFamily="34" charset="-120"/>
               </a:rPr>
-              <a:t>IMPACTO</a:t>
+              <a:t>IMPACTO · ESTIMATIVA A VALIDAR NO PILOTO</a:t>
             </a:r>
             <a:endParaRPr lang="en-US" sz="1150" dirty="0"/>
           </a:p>
@@ -5037,7 +5037,7 @@
                 <a:ea typeface="Calibri" pitchFamily="34" charset="-122"/>
                 <a:cs typeface="Calibri" pitchFamily="34" charset="-120"/>
               </a:rPr>
-              <a:t>Retorno direto — e ESG.</a:t>
+              <a:t>Quanto está em jogo — e como provamos.</a:t>
             </a:r>
             <a:endParaRPr lang="en-US" sz="3400" dirty="0"/>
           </a:p>
@@ -5178,7 +5178,7 @@
                 <a:ea typeface="Calibri" pitchFamily="34" charset="-122"/>
                 <a:cs typeface="Calibri" pitchFamily="34" charset="-120"/>
               </a:rPr>
-              <a:t>+R$ 1.200</a:t>
+              <a:t>≈ R$ 1.250</a:t>
             </a:r>
             <a:endParaRPr lang="en-US" sz="4000" dirty="0"/>
           </a:p>
@@ -5217,7 +5217,7 @@
                 <a:ea typeface="Calibri" pitchFamily="34" charset="-122"/>
                 <a:cs typeface="Calibri" pitchFamily="34" charset="-120"/>
               </a:rPr>
-              <a:t>por produtor / mês</a:t>
+              <a:t>por produtor / mês em jogo</a:t>
             </a:r>
             <a:endParaRPr lang="en-US" sz="1250" dirty="0"/>
           </a:p>
@@ -5234,7 +5234,7 @@
                 <a:ea typeface="Calibri" pitchFamily="34" charset="-122"/>
                 <a:cs typeface="Calibri" pitchFamily="34" charset="-120"/>
               </a:rPr>
-              <a:t>ganho ou perda evitada</a:t>
+              <a:t>simulação · produtor-alvo 400 L/dia</a:t>
             </a:r>
             <a:endParaRPr lang="en-US" sz="1250" dirty="0"/>
           </a:p>
@@ -5273,7 +5273,7 @@
                 <a:ea typeface="Calibri" pitchFamily="34" charset="-122"/>
                 <a:cs typeface="Calibri" pitchFamily="34" charset="-120"/>
               </a:rPr>
-              <a:t>50–60%</a:t>
+              <a:t>60–90 dias</a:t>
             </a:r>
             <a:endParaRPr lang="en-US" sz="4000" dirty="0"/>
           </a:p>
@@ -5312,7 +5312,7 @@
                 <a:ea typeface="Calibri" pitchFamily="34" charset="-122"/>
                 <a:cs typeface="Calibri" pitchFamily="34" charset="-120"/>
               </a:rPr>
-              <a:t>menos descarte</a:t>
+              <a:t>até o relatório de ROI do piloto</a:t>
             </a:r>
             <a:endParaRPr lang="en-US" sz="1250" dirty="0"/>
           </a:p>
@@ -5329,7 +5329,7 @@
                 <a:ea typeface="Calibri" pitchFamily="34" charset="-122"/>
                 <a:cs typeface="Calibri" pitchFamily="34" charset="-120"/>
               </a:rPr>
-              <a:t>de leite não-conforme</a:t>
+              <a:t>com os dados do próprio laticínio</a:t>
             </a:r>
             <a:endParaRPr lang="en-US" sz="1250" dirty="0"/>
           </a:p>
@@ -5368,7 +5368,7 @@
                 <a:ea typeface="Calibri" pitchFamily="34" charset="-122"/>
                 <a:cs typeface="Calibri" pitchFamily="34" charset="-120"/>
               </a:rPr>
-              <a:t>180+ t</a:t>
+              <a:t>~180 t</a:t>
             </a:r>
             <a:endParaRPr lang="en-US" sz="4000" dirty="0"/>
           </a:p>
@@ -5407,7 +5407,7 @@
                 <a:ea typeface="Calibri" pitchFamily="34" charset="-122"/>
                 <a:cs typeface="Calibri" pitchFamily="34" charset="-120"/>
               </a:rPr>
-              <a:t>CO₂ evitado / ano</a:t>
+              <a:t>CO₂-eq evitável / ano</a:t>
             </a:r>
             <a:endParaRPr lang="en-US" sz="1250" dirty="0"/>
           </a:p>
@@ -5424,7 +5424,7 @@
                 <a:ea typeface="Calibri" pitchFamily="34" charset="-122"/>
                 <a:cs typeface="Calibri" pitchFamily="34" charset="-120"/>
               </a:rPr>
-              <a:t>cooperativa de 50 produtores</a:t>
+              <a:t>50 produtores · 4 L/dia a menos</a:t>
             </a:r>
             <a:endParaRPr lang="en-US" sz="1250" dirty="0"/>
           </a:p>
@@ -5463,7 +5463,7 @@
                 <a:ea typeface="Calibri" pitchFamily="34" charset="-122"/>
                 <a:cs typeface="Calibri" pitchFamily="34" charset="-120"/>
               </a:rPr>
-              <a:t>Base (produtor médio ~400 L/dia): bônus protegido ~R$ 960 + descarte evitado ~R$ 294 (4 L/dia). CO₂: ~73 mil L/ano evitados × 2,5 kg CO₂-eq/L.</a:t>
+              <a:t>Premissas: bônus R$ 0,08/L × 12.000 L/mês ≈ R$ 960 + descarte evitado 4 L/dia × R$ 2,45/L (IBGE/SIDRA 2024) ≈ R$ 294. CO₂: 73 mil L/ano × 2,5 kg/L (FAO, 2010).</a:t>
             </a:r>
             <a:endParaRPr lang="en-US" sz="950" dirty="0"/>
           </a:p>
@@ -5502,7 +5502,7 @@
                 <a:ea typeface="Calibri" pitchFamily="34" charset="-122"/>
                 <a:cs typeface="Calibri" pitchFamily="34" charset="-120"/>
               </a:rPr>
-              <a:t>Benchmarks: Embrapa · MAPA IN 77/2018 · FAO (2010). Memória de cálculo detalhada no plano de negócio.</a:t>
+              <a:t>Bônus e descarte variam por laticínio: são as primeiras métricas medidas no piloto. Memória de cálculo no plano de negócio.</a:t>
             </a:r>
             <a:endParaRPr lang="en-US" sz="950" dirty="0"/>
           </a:p>

</xml_diff>